<commit_message>
Apertura 30/10: reel, story 1 y carrusel con las fotos actuales de la web
Co-Authored-By: Claude Opus 5.5 <noreply@anthropic.com>
Claude-Session: https://claude.ai/code/session_01QDay3CjVQPJM1nCQWTB6Yu
</commit_message>
<xml_diff>
--- a/public/ig/2026-10-30-nuevas/2026-10-30-carrusel-canva.pptx
+++ b/public/ig/2026-10-30-nuevas/2026-10-30-carrusel-canva.pptx
@@ -3103,12 +3103,21 @@
         <p:nvPr/>
       </p:nvGrpSpPr>
       <p:grpSpPr/>
-      <p:sp>
-        <p:nvSpPr>
-          <p:cNvPr id="2" name="Rectangle 1"/>
-          <p:cNvSpPr/>
+      <p:pic>
+        <p:nvPicPr>
+          <p:cNvPr id="2" name="Picture 1" descr="nosotras-10-anos.jpg"/>
+          <p:cNvPicPr>
+            <a:picLocks noChangeAspect="1"/>
+          </p:cNvPicPr>
           <p:nvPr/>
-        </p:nvSpPr>
+        </p:nvPicPr>
+        <p:blipFill>
+          <a:blip r:embed="rId2"/>
+          <a:srcRect t="6656" b="9984"/>
+          <a:stretch>
+            <a:fillRect/>
+          </a:stretch>
+        </p:blipFill>
         <p:spPr>
           <a:xfrm>
             <a:off x="0" y="0"/>
@@ -3117,8 +3126,26 @@
           <a:prstGeom prst="rect">
             <a:avLst/>
           </a:prstGeom>
+        </p:spPr>
+      </p:pic>
+      <p:sp>
+        <p:nvSpPr>
+          <p:cNvPr id="3" name="Rounded Rectangle 2"/>
+          <p:cNvSpPr/>
+          <p:nvPr/>
+        </p:nvSpPr>
+        <p:spPr>
+          <a:xfrm>
+            <a:off x="457200" y="5781294"/>
+            <a:ext cx="9372600" cy="6029706"/>
+          </a:xfrm>
+          <a:prstGeom prst="roundRect">
+            <a:avLst>
+              <a:gd name="adj" fmla="val 6000"/>
+            </a:avLst>
+          </a:prstGeom>
           <a:solidFill>
-            <a:srgbClr val="EBDCDC"/>
+            <a:srgbClr val="F3F3F5"/>
           </a:solidFill>
           <a:ln>
             <a:noFill/>
@@ -3148,14 +3175,14 @@
       </p:sp>
       <p:sp>
         <p:nvSpPr>
-          <p:cNvPr id="3" name="TextBox 2"/>
+          <p:cNvPr id="4" name="TextBox 3"/>
           <p:cNvSpPr txBox="1"/>
           <p:nvPr/>
         </p:nvSpPr>
         <p:spPr>
           <a:xfrm>
-            <a:off x="571500" y="0"/>
-            <a:ext cx="9144000" cy="6429375"/>
+            <a:off x="914400" y="6305550"/>
+            <a:ext cx="8458200" cy="381000"/>
           </a:xfrm>
           <a:prstGeom prst="rect">
             <a:avLst/>
@@ -3163,54 +3190,88 @@
           <a:noFill/>
         </p:spPr>
         <p:txBody>
-          <a:bodyPr wrap="square" anchor="ctr" lIns="0" rIns="0" tIns="0" bIns="0">
+          <a:bodyPr wrap="square" anchor="t" lIns="0" rIns="0" tIns="0" bIns="0">
             <a:spAutoFit/>
           </a:bodyPr>
           <a:lstStyle/>
           <a:p>
-            <a:pPr algn="ctr"/>
-            <a:r>
-              <a:rPr sz="2550" i="0">
-                <a:solidFill>
-                  <a:srgbClr val="6B6D78"/>
+            <a:pPr algn="l"/>
+            <a:r>
+              <a:rPr sz="2250" i="0">
+                <a:solidFill>
+                  <a:srgbClr val="8E5A5E"/>
                 </a:solidFill>
                 <a:latin typeface="Jost"/>
               </a:rPr>
-              <a:t>FOTO (cámbiala en Canva)</a:t>
-            </a:r>
-          </a:p>
-          <a:p>
-            <a:pPr algn="ctr"/>
-            <a:r>
-              <a:rPr sz="2550" i="0">
-                <a:solidFill>
-                  <a:srgbClr val="6B6D78"/>
-                </a:solidFill>
-                <a:latin typeface="Jost"/>
+              <a:t>HOY ABRIMOS</a:t>
+            </a:r>
+          </a:p>
+        </p:txBody>
+      </p:sp>
+      <p:sp>
+        <p:nvSpPr>
+          <p:cNvPr id="5" name="TextBox 4"/>
+          <p:cNvSpPr txBox="1"/>
+          <p:nvPr/>
+        </p:nvSpPr>
+        <p:spPr>
+          <a:xfrm>
+            <a:off x="914400" y="7105650"/>
+            <a:ext cx="8458200" cy="2688336"/>
+          </a:xfrm>
+          <a:prstGeom prst="rect">
+            <a:avLst/>
+          </a:prstGeom>
+          <a:noFill/>
+        </p:spPr>
+        <p:txBody>
+          <a:bodyPr wrap="square" anchor="t" lIns="0" rIns="0" tIns="0" bIns="0">
+            <a:spAutoFit/>
+          </a:bodyPr>
+          <a:lstStyle/>
+          <a:p>
+            <a:pPr algn="l">
+              <a:lnSpc>
+                <a:spcPct val="100000"/>
+              </a:lnSpc>
+            </a:pPr>
+            <a:r>
+              <a:rPr sz="6300" i="0">
+                <a:solidFill>
+                  <a:srgbClr val="22232B"/>
+                </a:solidFill>
+                <a:latin typeface="Bodoni Moda"/>
               </a:rPr>
-              <a:t>Aquí va una foto: la de portada de la web</a:t>
-            </a:r>
-          </a:p>
-        </p:txBody>
-      </p:sp>
-      <p:sp>
-        <p:nvSpPr>
-          <p:cNvPr id="4" name="Rounded Rectangle 3"/>
+              <a:t>La escuela que nos habría gustado </a:t>
+            </a:r>
+            <a:r>
+              <a:rPr sz="6300" i="1">
+                <a:solidFill>
+                  <a:srgbClr val="8E5A5E"/>
+                </a:solidFill>
+                <a:latin typeface="Bodoni Moda"/>
+              </a:rPr>
+              <a:t>tener a nosotras</a:t>
+            </a:r>
+          </a:p>
+        </p:txBody>
+      </p:sp>
+      <p:sp>
+        <p:nvSpPr>
+          <p:cNvPr id="6" name="Rectangle 5"/>
           <p:cNvSpPr/>
           <p:nvPr/>
         </p:nvSpPr>
         <p:spPr>
           <a:xfrm>
-            <a:off x="457200" y="5781294"/>
-            <a:ext cx="9372600" cy="6029706"/>
-          </a:xfrm>
-          <a:prstGeom prst="roundRect">
-            <a:avLst>
-              <a:gd name="adj" fmla="val 6000"/>
-            </a:avLst>
+            <a:off x="914400" y="10220325"/>
+            <a:ext cx="1143000" cy="28575"/>
+          </a:xfrm>
+          <a:prstGeom prst="rect">
+            <a:avLst/>
           </a:prstGeom>
           <a:solidFill>
-            <a:srgbClr val="F3F3F5"/>
+            <a:srgbClr val="8E5A5E"/>
           </a:solidFill>
           <a:ln>
             <a:noFill/>
@@ -3240,133 +3301,7 @@
       </p:sp>
       <p:sp>
         <p:nvSpPr>
-          <p:cNvPr id="5" name="TextBox 4"/>
-          <p:cNvSpPr txBox="1"/>
-          <p:nvPr/>
-        </p:nvSpPr>
-        <p:spPr>
-          <a:xfrm>
-            <a:off x="914400" y="6305550"/>
-            <a:ext cx="8458200" cy="381000"/>
-          </a:xfrm>
-          <a:prstGeom prst="rect">
-            <a:avLst/>
-          </a:prstGeom>
-          <a:noFill/>
-        </p:spPr>
-        <p:txBody>
-          <a:bodyPr wrap="square" anchor="t" lIns="0" rIns="0" tIns="0" bIns="0">
-            <a:spAutoFit/>
-          </a:bodyPr>
-          <a:lstStyle/>
-          <a:p>
-            <a:pPr algn="l"/>
-            <a:r>
-              <a:rPr sz="2250" i="0">
-                <a:solidFill>
-                  <a:srgbClr val="8E5A5E"/>
-                </a:solidFill>
-                <a:latin typeface="Jost"/>
-              </a:rPr>
-              <a:t>HOY ABRIMOS</a:t>
-            </a:r>
-          </a:p>
-        </p:txBody>
-      </p:sp>
-      <p:sp>
-        <p:nvSpPr>
-          <p:cNvPr id="6" name="TextBox 5"/>
-          <p:cNvSpPr txBox="1"/>
-          <p:nvPr/>
-        </p:nvSpPr>
-        <p:spPr>
-          <a:xfrm>
-            <a:off x="914400" y="7105650"/>
-            <a:ext cx="8458200" cy="2688336"/>
-          </a:xfrm>
-          <a:prstGeom prst="rect">
-            <a:avLst/>
-          </a:prstGeom>
-          <a:noFill/>
-        </p:spPr>
-        <p:txBody>
-          <a:bodyPr wrap="square" anchor="t" lIns="0" rIns="0" tIns="0" bIns="0">
-            <a:spAutoFit/>
-          </a:bodyPr>
-          <a:lstStyle/>
-          <a:p>
-            <a:pPr algn="l">
-              <a:lnSpc>
-                <a:spcPct val="100000"/>
-              </a:lnSpc>
-            </a:pPr>
-            <a:r>
-              <a:rPr sz="6300" i="0">
-                <a:solidFill>
-                  <a:srgbClr val="22232B"/>
-                </a:solidFill>
-                <a:latin typeface="Bodoni Moda"/>
-              </a:rPr>
-              <a:t>La escuela que nos habría gustado </a:t>
-            </a:r>
-            <a:r>
-              <a:rPr sz="6300" i="1">
-                <a:solidFill>
-                  <a:srgbClr val="8E5A5E"/>
-                </a:solidFill>
-                <a:latin typeface="Bodoni Moda"/>
-              </a:rPr>
-              <a:t>tener a nosotras</a:t>
-            </a:r>
-          </a:p>
-        </p:txBody>
-      </p:sp>
-      <p:sp>
-        <p:nvSpPr>
-          <p:cNvPr id="7" name="Rectangle 6"/>
-          <p:cNvSpPr/>
-          <p:nvPr/>
-        </p:nvSpPr>
-        <p:spPr>
-          <a:xfrm>
-            <a:off x="914400" y="10220325"/>
-            <a:ext cx="1143000" cy="28575"/>
-          </a:xfrm>
-          <a:prstGeom prst="rect">
-            <a:avLst/>
-          </a:prstGeom>
-          <a:solidFill>
-            <a:srgbClr val="8E5A5E"/>
-          </a:solidFill>
-          <a:ln>
-            <a:noFill/>
-          </a:ln>
-        </p:spPr>
-        <p:style>
-          <a:lnRef idx="1">
-            <a:schemeClr val="accent1"/>
-          </a:lnRef>
-          <a:fillRef idx="3">
-            <a:schemeClr val="accent1"/>
-          </a:fillRef>
-          <a:effectRef idx="2">
-            <a:schemeClr val="accent1"/>
-          </a:effectRef>
-          <a:fontRef idx="minor">
-            <a:schemeClr val="lt1"/>
-          </a:fontRef>
-        </p:style>
-        <p:txBody>
-          <a:bodyPr rtlCol="0" anchor="ctr"/>
-          <a:lstStyle/>
-          <a:p>
-            <a:pPr algn="ctr"/>
-          </a:p>
-        </p:txBody>
-      </p:sp>
-      <p:sp>
-        <p:nvSpPr>
-          <p:cNvPr id="8" name="TextBox 7"/>
+          <p:cNvPr id="7" name="TextBox 6"/>
           <p:cNvSpPr txBox="1"/>
           <p:nvPr/>
         </p:nvSpPr>
@@ -3405,7 +3340,7 @@
       </p:sp>
       <p:sp>
         <p:nvSpPr>
-          <p:cNvPr id="9" name="TextBox 8"/>
+          <p:cNvPr id="8" name="TextBox 7"/>
           <p:cNvSpPr txBox="1"/>
           <p:nvPr/>
         </p:nvSpPr>
@@ -3449,7 +3384,7 @@
       </p:sp>
       <p:sp>
         <p:nvSpPr>
-          <p:cNvPr id="10" name="TextBox 9"/>
+          <p:cNvPr id="9" name="TextBox 8"/>
           <p:cNvSpPr txBox="1"/>
           <p:nvPr/>
         </p:nvSpPr>
@@ -4465,12 +4400,21 @@
         <p:nvPr/>
       </p:nvGrpSpPr>
       <p:grpSpPr/>
-      <p:sp>
-        <p:nvSpPr>
-          <p:cNvPr id="2" name="Rectangle 1"/>
-          <p:cNvSpPr/>
+      <p:pic>
+        <p:nvPicPr>
+          <p:cNvPr id="2" name="Picture 1" descr="ws-077.jpg"/>
+          <p:cNvPicPr>
+            <a:picLocks noChangeAspect="1"/>
+          </p:cNvPicPr>
           <p:nvPr/>
-        </p:nvSpPr>
+        </p:nvPicPr>
+        <p:blipFill>
+          <a:blip r:embed="rId2"/>
+          <a:srcRect l="16328" r="30323"/>
+          <a:stretch>
+            <a:fillRect/>
+          </a:stretch>
+        </p:blipFill>
         <p:spPr>
           <a:xfrm>
             <a:off x="0" y="0"/>
@@ -4479,8 +4423,26 @@
           <a:prstGeom prst="rect">
             <a:avLst/>
           </a:prstGeom>
+        </p:spPr>
+      </p:pic>
+      <p:sp>
+        <p:nvSpPr>
+          <p:cNvPr id="3" name="Rounded Rectangle 2"/>
+          <p:cNvSpPr/>
+          <p:nvPr/>
+        </p:nvSpPr>
+        <p:spPr>
+          <a:xfrm>
+            <a:off x="457200" y="6965822"/>
+            <a:ext cx="9372600" cy="4845177"/>
+          </a:xfrm>
+          <a:prstGeom prst="roundRect">
+            <a:avLst>
+              <a:gd name="adj" fmla="val 6000"/>
+            </a:avLst>
+          </a:prstGeom>
           <a:solidFill>
-            <a:srgbClr val="EBDCDC"/>
+            <a:srgbClr val="F3F3F5"/>
           </a:solidFill>
           <a:ln>
             <a:noFill/>
@@ -4510,14 +4472,14 @@
       </p:sp>
       <p:sp>
         <p:nvSpPr>
-          <p:cNvPr id="3" name="TextBox 2"/>
+          <p:cNvPr id="4" name="TextBox 3"/>
           <p:cNvSpPr txBox="1"/>
           <p:nvPr/>
         </p:nvSpPr>
         <p:spPr>
           <a:xfrm>
-            <a:off x="571500" y="0"/>
-            <a:ext cx="9144000" cy="6429375"/>
+            <a:off x="914400" y="7496175"/>
+            <a:ext cx="8458200" cy="381000"/>
           </a:xfrm>
           <a:prstGeom prst="rect">
             <a:avLst/>
@@ -4525,54 +4487,88 @@
           <a:noFill/>
         </p:spPr>
         <p:txBody>
-          <a:bodyPr wrap="square" anchor="ctr" lIns="0" rIns="0" tIns="0" bIns="0">
+          <a:bodyPr wrap="square" anchor="t" lIns="0" rIns="0" tIns="0" bIns="0">
             <a:spAutoFit/>
           </a:bodyPr>
           <a:lstStyle/>
           <a:p>
-            <a:pPr algn="ctr"/>
-            <a:r>
-              <a:rPr sz="2550" i="0">
-                <a:solidFill>
-                  <a:srgbClr val="6B6D78"/>
+            <a:pPr algn="l"/>
+            <a:r>
+              <a:rPr sz="2250" i="0">
+                <a:solidFill>
+                  <a:srgbClr val="8E5A5E"/>
                 </a:solidFill>
                 <a:latin typeface="Jost"/>
               </a:rPr>
-              <a:t>FOTO (cámbiala en Canva)</a:t>
-            </a:r>
-          </a:p>
-          <a:p>
-            <a:pPr algn="ctr"/>
-            <a:r>
-              <a:rPr sz="2550" i="0">
-                <a:solidFill>
-                  <a:srgbClr val="6B6D78"/>
-                </a:solidFill>
-                <a:latin typeface="Jost"/>
+              <a:t>SIGNATURE</a:t>
+            </a:r>
+          </a:p>
+        </p:txBody>
+      </p:sp>
+      <p:sp>
+        <p:nvSpPr>
+          <p:cNvPr id="5" name="TextBox 4"/>
+          <p:cNvSpPr txBox="1"/>
+          <p:nvPr/>
+        </p:nvSpPr>
+        <p:spPr>
+          <a:xfrm>
+            <a:off x="914400" y="8296275"/>
+            <a:ext cx="8458200" cy="896112"/>
+          </a:xfrm>
+          <a:prstGeom prst="rect">
+            <a:avLst/>
+          </a:prstGeom>
+          <a:noFill/>
+        </p:spPr>
+        <p:txBody>
+          <a:bodyPr wrap="square" anchor="t" lIns="0" rIns="0" tIns="0" bIns="0">
+            <a:spAutoFit/>
+          </a:bodyPr>
+          <a:lstStyle/>
+          <a:p>
+            <a:pPr algn="l">
+              <a:lnSpc>
+                <a:spcPct val="100000"/>
+              </a:lnSpc>
+            </a:pPr>
+            <a:r>
+              <a:rPr sz="6300" i="0">
+                <a:solidFill>
+                  <a:srgbClr val="22232B"/>
+                </a:solidFill>
+                <a:latin typeface="Bodoni Moda"/>
               </a:rPr>
-              <a:t>Aquí va una foto: el workshop presencial (alumnas trabajando)</a:t>
-            </a:r>
-          </a:p>
-        </p:txBody>
-      </p:sp>
-      <p:sp>
-        <p:nvSpPr>
-          <p:cNvPr id="4" name="Rounded Rectangle 3"/>
+              <a:t>Aprender </a:t>
+            </a:r>
+            <a:r>
+              <a:rPr sz="6300" i="1">
+                <a:solidFill>
+                  <a:srgbClr val="8E5A5E"/>
+                </a:solidFill>
+                <a:latin typeface="Bodoni Moda"/>
+              </a:rPr>
+              <a:t>haciendo</a:t>
+            </a:r>
+          </a:p>
+        </p:txBody>
+      </p:sp>
+      <p:sp>
+        <p:nvSpPr>
+          <p:cNvPr id="6" name="Rectangle 5"/>
           <p:cNvSpPr/>
           <p:nvPr/>
         </p:nvSpPr>
         <p:spPr>
           <a:xfrm>
-            <a:off x="457200" y="6965822"/>
-            <a:ext cx="9372600" cy="4845177"/>
-          </a:xfrm>
-          <a:prstGeom prst="roundRect">
-            <a:avLst>
-              <a:gd name="adj" fmla="val 6000"/>
-            </a:avLst>
+            <a:off x="914400" y="9610725"/>
+            <a:ext cx="1143000" cy="28575"/>
+          </a:xfrm>
+          <a:prstGeom prst="rect">
+            <a:avLst/>
           </a:prstGeom>
           <a:solidFill>
-            <a:srgbClr val="F3F3F5"/>
+            <a:srgbClr val="8E5A5E"/>
           </a:solidFill>
           <a:ln>
             <a:noFill/>
@@ -4602,133 +4598,7 @@
       </p:sp>
       <p:sp>
         <p:nvSpPr>
-          <p:cNvPr id="5" name="TextBox 4"/>
-          <p:cNvSpPr txBox="1"/>
-          <p:nvPr/>
-        </p:nvSpPr>
-        <p:spPr>
-          <a:xfrm>
-            <a:off x="914400" y="7496175"/>
-            <a:ext cx="8458200" cy="381000"/>
-          </a:xfrm>
-          <a:prstGeom prst="rect">
-            <a:avLst/>
-          </a:prstGeom>
-          <a:noFill/>
-        </p:spPr>
-        <p:txBody>
-          <a:bodyPr wrap="square" anchor="t" lIns="0" rIns="0" tIns="0" bIns="0">
-            <a:spAutoFit/>
-          </a:bodyPr>
-          <a:lstStyle/>
-          <a:p>
-            <a:pPr algn="l"/>
-            <a:r>
-              <a:rPr sz="2250" i="0">
-                <a:solidFill>
-                  <a:srgbClr val="8E5A5E"/>
-                </a:solidFill>
-                <a:latin typeface="Jost"/>
-              </a:rPr>
-              <a:t>SIGNATURE</a:t>
-            </a:r>
-          </a:p>
-        </p:txBody>
-      </p:sp>
-      <p:sp>
-        <p:nvSpPr>
-          <p:cNvPr id="6" name="TextBox 5"/>
-          <p:cNvSpPr txBox="1"/>
-          <p:nvPr/>
-        </p:nvSpPr>
-        <p:spPr>
-          <a:xfrm>
-            <a:off x="914400" y="8296275"/>
-            <a:ext cx="8458200" cy="896112"/>
-          </a:xfrm>
-          <a:prstGeom prst="rect">
-            <a:avLst/>
-          </a:prstGeom>
-          <a:noFill/>
-        </p:spPr>
-        <p:txBody>
-          <a:bodyPr wrap="square" anchor="t" lIns="0" rIns="0" tIns="0" bIns="0">
-            <a:spAutoFit/>
-          </a:bodyPr>
-          <a:lstStyle/>
-          <a:p>
-            <a:pPr algn="l">
-              <a:lnSpc>
-                <a:spcPct val="100000"/>
-              </a:lnSpc>
-            </a:pPr>
-            <a:r>
-              <a:rPr sz="6300" i="0">
-                <a:solidFill>
-                  <a:srgbClr val="22232B"/>
-                </a:solidFill>
-                <a:latin typeface="Bodoni Moda"/>
-              </a:rPr>
-              <a:t>Aprender </a:t>
-            </a:r>
-            <a:r>
-              <a:rPr sz="6300" i="1">
-                <a:solidFill>
-                  <a:srgbClr val="8E5A5E"/>
-                </a:solidFill>
-                <a:latin typeface="Bodoni Moda"/>
-              </a:rPr>
-              <a:t>haciendo</a:t>
-            </a:r>
-          </a:p>
-        </p:txBody>
-      </p:sp>
-      <p:sp>
-        <p:nvSpPr>
-          <p:cNvPr id="7" name="Rectangle 6"/>
-          <p:cNvSpPr/>
-          <p:nvPr/>
-        </p:nvSpPr>
-        <p:spPr>
-          <a:xfrm>
-            <a:off x="914400" y="9610725"/>
-            <a:ext cx="1143000" cy="28575"/>
-          </a:xfrm>
-          <a:prstGeom prst="rect">
-            <a:avLst/>
-          </a:prstGeom>
-          <a:solidFill>
-            <a:srgbClr val="8E5A5E"/>
-          </a:solidFill>
-          <a:ln>
-            <a:noFill/>
-          </a:ln>
-        </p:spPr>
-        <p:style>
-          <a:lnRef idx="1">
-            <a:schemeClr val="accent1"/>
-          </a:lnRef>
-          <a:fillRef idx="3">
-            <a:schemeClr val="accent1"/>
-          </a:fillRef>
-          <a:effectRef idx="2">
-            <a:schemeClr val="accent1"/>
-          </a:effectRef>
-          <a:fontRef idx="minor">
-            <a:schemeClr val="lt1"/>
-          </a:fontRef>
-        </p:style>
-        <p:txBody>
-          <a:bodyPr rtlCol="0" anchor="ctr"/>
-          <a:lstStyle/>
-          <a:p>
-            <a:pPr algn="ctr"/>
-          </a:p>
-        </p:txBody>
-      </p:sp>
-      <p:sp>
-        <p:nvSpPr>
-          <p:cNvPr id="8" name="TextBox 7"/>
+          <p:cNvPr id="7" name="TextBox 6"/>
           <p:cNvSpPr txBox="1"/>
           <p:nvPr/>
         </p:nvSpPr>
@@ -4767,7 +4637,7 @@
       </p:sp>
       <p:sp>
         <p:nvSpPr>
-          <p:cNvPr id="9" name="TextBox 8"/>
+          <p:cNvPr id="8" name="TextBox 7"/>
           <p:cNvSpPr txBox="1"/>
           <p:nvPr/>
         </p:nvSpPr>
@@ -4811,7 +4681,7 @@
       </p:sp>
       <p:sp>
         <p:nvSpPr>
-          <p:cNvPr id="10" name="TextBox 9"/>
+          <p:cNvPr id="9" name="TextBox 8"/>
           <p:cNvSpPr txBox="1"/>
           <p:nvPr/>
         </p:nvSpPr>

</xml_diff>

<commit_message>
Apertura 30/10: carrusel 2, 3 y 5 con la web en el móvil y archivos de Canva con el móvil incluido
Co-Authored-By: Claude Opus 5.5 <noreply@anthropic.com>
Claude-Session: https://claude.ai/code/session_01QDay3CjVQPJM1nCQWTB6Yu
</commit_message>
<xml_diff>
--- a/public/ig/2026-10-30-nuevas/2026-10-30-carrusel-canva.pptx
+++ b/public/ig/2026-10-30-nuevas/2026-10-30-carrusel-canva.pptx
@@ -3443,16 +3443,40 @@
         <p:nvPr/>
       </p:nvGrpSpPr>
       <p:grpSpPr/>
-      <p:sp>
-        <p:nvSpPr>
-          <p:cNvPr id="2" name="TextBox 1"/>
+      <p:pic>
+        <p:nvPicPr>
+          <p:cNvPr id="2" name="Picture 1" descr=".c2-movil.png"/>
+          <p:cNvPicPr>
+            <a:picLocks noChangeAspect="1"/>
+          </p:cNvPicPr>
+          <p:nvPr/>
+        </p:nvPicPr>
+        <p:blipFill>
+          <a:blip r:embed="rId2"/>
+          <a:stretch>
+            <a:fillRect/>
+          </a:stretch>
+        </p:blipFill>
+        <p:spPr>
+          <a:xfrm>
+            <a:off x="0" y="5038725"/>
+            <a:ext cx="10287000" cy="7820025"/>
+          </a:xfrm>
+          <a:prstGeom prst="rect">
+            <a:avLst/>
+          </a:prstGeom>
+        </p:spPr>
+      </p:pic>
+      <p:sp>
+        <p:nvSpPr>
+          <p:cNvPr id="3" name="TextBox 2"/>
           <p:cNvSpPr txBox="1"/>
           <p:nvPr/>
         </p:nvSpPr>
         <p:spPr>
           <a:xfrm>
-            <a:off x="914400" y="5753100"/>
-            <a:ext cx="8458200" cy="896112"/>
+            <a:off x="857250" y="1428750"/>
+            <a:ext cx="8572500" cy="381000"/>
           </a:xfrm>
           <a:prstGeom prst="rect">
             <a:avLst/>
@@ -3465,76 +3489,77 @@
           </a:bodyPr>
           <a:lstStyle/>
           <a:p>
-            <a:pPr algn="l">
+            <a:pPr algn="ctr"/>
+            <a:r>
+              <a:rPr sz="2250" i="0">
+                <a:solidFill>
+                  <a:srgbClr val="8E5A5E"/>
+                </a:solidFill>
+                <a:latin typeface="Jost"/>
+              </a:rPr>
+              <a:t>LA WEB</a:t>
+            </a:r>
+          </a:p>
+        </p:txBody>
+      </p:sp>
+      <p:sp>
+        <p:nvSpPr>
+          <p:cNvPr id="4" name="TextBox 3"/>
+          <p:cNvSpPr txBox="1"/>
+          <p:nvPr/>
+        </p:nvSpPr>
+        <p:spPr>
+          <a:xfrm>
+            <a:off x="857250" y="2000250"/>
+            <a:ext cx="8572500" cy="1508760"/>
+          </a:xfrm>
+          <a:prstGeom prst="rect">
+            <a:avLst/>
+          </a:prstGeom>
+          <a:noFill/>
+        </p:spPr>
+        <p:txBody>
+          <a:bodyPr wrap="square" anchor="t" lIns="0" rIns="0" tIns="0" bIns="0">
+            <a:spAutoFit/>
+          </a:bodyPr>
+          <a:lstStyle/>
+          <a:p>
+            <a:pPr algn="ctr">
               <a:lnSpc>
                 <a:spcPct val="100000"/>
               </a:lnSpc>
             </a:pPr>
             <a:r>
-              <a:rPr sz="6300" i="0">
+              <a:rPr sz="5400" i="0">
                 <a:solidFill>
                   <a:srgbClr val="22232B"/>
                 </a:solidFill>
                 <a:latin typeface="Bodoni Moda"/>
               </a:rPr>
-              <a:t>x</a:t>
-            </a:r>
-          </a:p>
-        </p:txBody>
-      </p:sp>
-      <p:sp>
-        <p:nvSpPr>
-          <p:cNvPr id="3" name="Rectangle 2"/>
-          <p:cNvSpPr/>
-          <p:nvPr/>
-        </p:nvSpPr>
-        <p:spPr>
-          <a:xfrm>
-            <a:off x="914400" y="7067550"/>
-            <a:ext cx="1143000" cy="28575"/>
-          </a:xfrm>
-          <a:prstGeom prst="rect">
-            <a:avLst/>
-          </a:prstGeom>
-          <a:solidFill>
-            <a:srgbClr val="8E5A5E"/>
-          </a:solidFill>
-          <a:ln>
-            <a:noFill/>
-          </a:ln>
-        </p:spPr>
-        <p:style>
-          <a:lnRef idx="1">
-            <a:schemeClr val="accent1"/>
-          </a:lnRef>
-          <a:fillRef idx="3">
-            <a:schemeClr val="accent1"/>
-          </a:fillRef>
-          <a:effectRef idx="2">
-            <a:schemeClr val="accent1"/>
-          </a:effectRef>
-          <a:fontRef idx="minor">
-            <a:schemeClr val="lt1"/>
-          </a:fontRef>
-        </p:style>
-        <p:txBody>
-          <a:bodyPr rtlCol="0" anchor="ctr"/>
-          <a:lstStyle/>
-          <a:p>
-            <a:pPr algn="ctr"/>
-          </a:p>
-        </p:txBody>
-      </p:sp>
-      <p:sp>
-        <p:nvSpPr>
-          <p:cNvPr id="4" name="TextBox 3"/>
+              <a:t>Una escuela para </a:t>
+            </a:r>
+            <a:r>
+              <a:rPr sz="5400" i="1">
+                <a:solidFill>
+                  <a:srgbClr val="8E5A5E"/>
+                </a:solidFill>
+                <a:latin typeface="Bodoni Moda"/>
+              </a:rPr>
+              <a:t>aprender el oficio</a:t>
+            </a:r>
+          </a:p>
+        </p:txBody>
+      </p:sp>
+      <p:sp>
+        <p:nvSpPr>
+          <p:cNvPr id="5" name="TextBox 4"/>
           <p:cNvSpPr txBox="1"/>
           <p:nvPr/>
         </p:nvSpPr>
         <p:spPr>
           <a:xfrm>
-            <a:off x="914400" y="666750"/>
-            <a:ext cx="6667500" cy="476250"/>
+            <a:off x="857250" y="3699510"/>
+            <a:ext cx="8572500" cy="1053465"/>
           </a:xfrm>
           <a:prstGeom prst="rect">
             <a:avLst/>
@@ -3547,6 +3572,45 @@
           </a:bodyPr>
           <a:lstStyle/>
           <a:p>
+            <a:pPr algn="ctr">
+              <a:lnSpc>
+                <a:spcPct val="120000"/>
+              </a:lnSpc>
+            </a:pPr>
+            <a:r>
+              <a:rPr sz="2550" i="0">
+                <a:solidFill>
+                  <a:srgbClr val="22232B"/>
+                </a:solidFill>
+                <a:latin typeface="Jost"/>
+              </a:rPr>
+              <a:t>The Wedding Creators, el programa con el que formamos wedding planners, ahora también online.</a:t>
+            </a:r>
+          </a:p>
+        </p:txBody>
+      </p:sp>
+      <p:sp>
+        <p:nvSpPr>
+          <p:cNvPr id="6" name="TextBox 5"/>
+          <p:cNvSpPr txBox="1"/>
+          <p:nvPr/>
+        </p:nvSpPr>
+        <p:spPr>
+          <a:xfrm>
+            <a:off x="914400" y="666750"/>
+            <a:ext cx="6667500" cy="476250"/>
+          </a:xfrm>
+          <a:prstGeom prst="rect">
+            <a:avLst/>
+          </a:prstGeom>
+          <a:noFill/>
+        </p:spPr>
+        <p:txBody>
+          <a:bodyPr wrap="square" anchor="t" lIns="0" rIns="0" tIns="0" bIns="0">
+            <a:spAutoFit/>
+          </a:bodyPr>
+          <a:lstStyle/>
+          <a:p>
             <a:pPr algn="l"/>
             <a:r>
               <a:rPr sz="2550" i="0">
@@ -3571,7 +3635,7 @@
       </p:sp>
       <p:sp>
         <p:nvSpPr>
-          <p:cNvPr id="5" name="TextBox 4"/>
+          <p:cNvPr id="7" name="TextBox 6"/>
           <p:cNvSpPr txBox="1"/>
           <p:nvPr/>
         </p:nvSpPr>
@@ -3618,7 +3682,7 @@
     <p:bg>
       <p:bgPr>
         <a:solidFill>
-          <a:srgbClr val="F3F3F5"/>
+          <a:srgbClr val="F2E8E8"/>
         </a:solidFill>
         <a:effectLst/>
       </p:bgPr>
@@ -3630,16 +3694,40 @@
         <p:nvPr/>
       </p:nvGrpSpPr>
       <p:grpSpPr/>
-      <p:sp>
-        <p:nvSpPr>
-          <p:cNvPr id="2" name="TextBox 1"/>
+      <p:pic>
+        <p:nvPicPr>
+          <p:cNvPr id="2" name="Picture 1" descr=".c3-movil.png"/>
+          <p:cNvPicPr>
+            <a:picLocks noChangeAspect="1"/>
+          </p:cNvPicPr>
+          <p:nvPr/>
+        </p:nvPicPr>
+        <p:blipFill>
+          <a:blip r:embed="rId2"/>
+          <a:stretch>
+            <a:fillRect/>
+          </a:stretch>
+        </p:blipFill>
+        <p:spPr>
+          <a:xfrm>
+            <a:off x="0" y="5038725"/>
+            <a:ext cx="10287000" cy="7820025"/>
+          </a:xfrm>
+          <a:prstGeom prst="rect">
+            <a:avLst/>
+          </a:prstGeom>
+        </p:spPr>
+      </p:pic>
+      <p:sp>
+        <p:nvSpPr>
+          <p:cNvPr id="3" name="TextBox 2"/>
           <p:cNvSpPr txBox="1"/>
           <p:nvPr/>
         </p:nvSpPr>
         <p:spPr>
           <a:xfrm>
-            <a:off x="914400" y="5753100"/>
-            <a:ext cx="8458200" cy="896112"/>
+            <a:off x="857250" y="1428750"/>
+            <a:ext cx="8572500" cy="381000"/>
           </a:xfrm>
           <a:prstGeom prst="rect">
             <a:avLst/>
@@ -3652,76 +3740,77 @@
           </a:bodyPr>
           <a:lstStyle/>
           <a:p>
-            <a:pPr algn="l">
+            <a:pPr algn="ctr"/>
+            <a:r>
+              <a:rPr sz="2250" i="0">
+                <a:solidFill>
+                  <a:srgbClr val="8E5A5E"/>
+                </a:solidFill>
+                <a:latin typeface="Jost"/>
+              </a:rPr>
+              <a:t>PARA EMPEZAR</a:t>
+            </a:r>
+          </a:p>
+        </p:txBody>
+      </p:sp>
+      <p:sp>
+        <p:nvSpPr>
+          <p:cNvPr id="4" name="TextBox 3"/>
+          <p:cNvSpPr txBox="1"/>
+          <p:nvPr/>
+        </p:nvSpPr>
+        <p:spPr>
+          <a:xfrm>
+            <a:off x="857250" y="2000250"/>
+            <a:ext cx="8572500" cy="1508760"/>
+          </a:xfrm>
+          <a:prstGeom prst="rect">
+            <a:avLst/>
+          </a:prstGeom>
+          <a:noFill/>
+        </p:spPr>
+        <p:txBody>
+          <a:bodyPr wrap="square" anchor="t" lIns="0" rIns="0" tIns="0" bIns="0">
+            <a:spAutoFit/>
+          </a:bodyPr>
+          <a:lstStyle/>
+          <a:p>
+            <a:pPr algn="ctr">
               <a:lnSpc>
                 <a:spcPct val="100000"/>
               </a:lnSpc>
             </a:pPr>
             <a:r>
-              <a:rPr sz="6300" i="0">
+              <a:rPr sz="5400" i="0">
                 <a:solidFill>
                   <a:srgbClr val="22232B"/>
                 </a:solidFill>
                 <a:latin typeface="Bodoni Moda"/>
               </a:rPr>
-              <a:t>x</a:t>
-            </a:r>
-          </a:p>
-        </p:txBody>
-      </p:sp>
-      <p:sp>
-        <p:nvSpPr>
-          <p:cNvPr id="3" name="Rectangle 2"/>
-          <p:cNvSpPr/>
-          <p:nvPr/>
-        </p:nvSpPr>
-        <p:spPr>
-          <a:xfrm>
-            <a:off x="914400" y="7067550"/>
-            <a:ext cx="1143000" cy="28575"/>
-          </a:xfrm>
-          <a:prstGeom prst="rect">
-            <a:avLst/>
-          </a:prstGeom>
-          <a:solidFill>
-            <a:srgbClr val="8E5A5E"/>
-          </a:solidFill>
-          <a:ln>
-            <a:noFill/>
-          </a:ln>
-        </p:spPr>
-        <p:style>
-          <a:lnRef idx="1">
-            <a:schemeClr val="accent1"/>
-          </a:lnRef>
-          <a:fillRef idx="3">
-            <a:schemeClr val="accent1"/>
-          </a:fillRef>
-          <a:effectRef idx="2">
-            <a:schemeClr val="accent1"/>
-          </a:effectRef>
-          <a:fontRef idx="minor">
-            <a:schemeClr val="lt1"/>
-          </a:fontRef>
-        </p:style>
-        <p:txBody>
-          <a:bodyPr rtlCol="0" anchor="ctr"/>
-          <a:lstStyle/>
-          <a:p>
-            <a:pPr algn="ctr"/>
-          </a:p>
-        </p:txBody>
-      </p:sp>
-      <p:sp>
-        <p:nvSpPr>
-          <p:cNvPr id="4" name="TextBox 3"/>
+              <a:t>Wedding Planner </a:t>
+            </a:r>
+            <a:r>
+              <a:rPr sz="5400" i="1">
+                <a:solidFill>
+                  <a:srgbClr val="8E5A5E"/>
+                </a:solidFill>
+                <a:latin typeface="Bodoni Moda"/>
+              </a:rPr>
+              <a:t>Bootcamp</a:t>
+            </a:r>
+          </a:p>
+        </p:txBody>
+      </p:sp>
+      <p:sp>
+        <p:nvSpPr>
+          <p:cNvPr id="5" name="TextBox 4"/>
           <p:cNvSpPr txBox="1"/>
           <p:nvPr/>
         </p:nvSpPr>
         <p:spPr>
           <a:xfrm>
-            <a:off x="914400" y="666750"/>
-            <a:ext cx="6667500" cy="476250"/>
+            <a:off x="857250" y="3699510"/>
+            <a:ext cx="8572500" cy="1053465"/>
           </a:xfrm>
           <a:prstGeom prst="rect">
             <a:avLst/>
@@ -3734,6 +3823,45 @@
           </a:bodyPr>
           <a:lstStyle/>
           <a:p>
+            <a:pPr algn="ctr">
+              <a:lnSpc>
+                <a:spcPct val="120000"/>
+              </a:lnSpc>
+            </a:pPr>
+            <a:r>
+              <a:rPr sz="2550" i="0">
+                <a:solidFill>
+                  <a:srgbClr val="22232B"/>
+                </a:solidFill>
+                <a:latin typeface="Jost"/>
+              </a:rPr>
+              <a:t>7 días, una boda de práctica y 4 herramientas profesionales. 47 € IVA incluido.</a:t>
+            </a:r>
+          </a:p>
+        </p:txBody>
+      </p:sp>
+      <p:sp>
+        <p:nvSpPr>
+          <p:cNvPr id="6" name="TextBox 5"/>
+          <p:cNvSpPr txBox="1"/>
+          <p:nvPr/>
+        </p:nvSpPr>
+        <p:spPr>
+          <a:xfrm>
+            <a:off x="914400" y="666750"/>
+            <a:ext cx="6667500" cy="476250"/>
+          </a:xfrm>
+          <a:prstGeom prst="rect">
+            <a:avLst/>
+          </a:prstGeom>
+          <a:noFill/>
+        </p:spPr>
+        <p:txBody>
+          <a:bodyPr wrap="square" anchor="t" lIns="0" rIns="0" tIns="0" bIns="0">
+            <a:spAutoFit/>
+          </a:bodyPr>
+          <a:lstStyle/>
+          <a:p>
             <a:pPr algn="l"/>
             <a:r>
               <a:rPr sz="2550" i="0">
@@ -3758,7 +3886,7 @@
       </p:sp>
       <p:sp>
         <p:nvSpPr>
-          <p:cNvPr id="5" name="TextBox 4"/>
+          <p:cNvPr id="7" name="TextBox 6"/>
           <p:cNvSpPr txBox="1"/>
           <p:nvPr/>
         </p:nvSpPr>
@@ -4213,16 +4341,40 @@
         <p:nvPr/>
       </p:nvGrpSpPr>
       <p:grpSpPr/>
-      <p:sp>
-        <p:nvSpPr>
-          <p:cNvPr id="2" name="TextBox 1"/>
+      <p:pic>
+        <p:nvPicPr>
+          <p:cNvPr id="2" name="Picture 1" descr=".c5-movil.png"/>
+          <p:cNvPicPr>
+            <a:picLocks noChangeAspect="1"/>
+          </p:cNvPicPr>
+          <p:nvPr/>
+        </p:nvPicPr>
+        <p:blipFill>
+          <a:blip r:embed="rId2"/>
+          <a:stretch>
+            <a:fillRect/>
+          </a:stretch>
+        </p:blipFill>
+        <p:spPr>
+          <a:xfrm>
+            <a:off x="0" y="4581525"/>
+            <a:ext cx="10287000" cy="8277225"/>
+          </a:xfrm>
+          <a:prstGeom prst="rect">
+            <a:avLst/>
+          </a:prstGeom>
+        </p:spPr>
+      </p:pic>
+      <p:sp>
+        <p:nvSpPr>
+          <p:cNvPr id="3" name="TextBox 2"/>
           <p:cNvSpPr txBox="1"/>
           <p:nvPr/>
         </p:nvSpPr>
         <p:spPr>
           <a:xfrm>
-            <a:off x="914400" y="5753100"/>
-            <a:ext cx="8458200" cy="896112"/>
+            <a:off x="857250" y="1428750"/>
+            <a:ext cx="8572500" cy="381000"/>
           </a:xfrm>
           <a:prstGeom prst="rect">
             <a:avLst/>
@@ -4235,76 +4387,77 @@
           </a:bodyPr>
           <a:lstStyle/>
           <a:p>
-            <a:pPr algn="l">
+            <a:pPr algn="ctr"/>
+            <a:r>
+              <a:rPr sz="2250" i="0">
+                <a:solidFill>
+                  <a:srgbClr val="8E5A5E"/>
+                </a:solidFill>
+                <a:latin typeface="Jost"/>
+              </a:rPr>
+              <a:t>EL PROGRAMA</a:t>
+            </a:r>
+          </a:p>
+        </p:txBody>
+      </p:sp>
+      <p:sp>
+        <p:nvSpPr>
+          <p:cNvPr id="4" name="TextBox 3"/>
+          <p:cNvSpPr txBox="1"/>
+          <p:nvPr/>
+        </p:nvSpPr>
+        <p:spPr>
+          <a:xfrm>
+            <a:off x="857250" y="2000250"/>
+            <a:ext cx="8572500" cy="1508760"/>
+          </a:xfrm>
+          <a:prstGeom prst="rect">
+            <a:avLst/>
+          </a:prstGeom>
+          <a:noFill/>
+        </p:spPr>
+        <p:txBody>
+          <a:bodyPr wrap="square" anchor="t" lIns="0" rIns="0" tIns="0" bIns="0">
+            <a:spAutoFit/>
+          </a:bodyPr>
+          <a:lstStyle/>
+          <a:p>
+            <a:pPr algn="ctr">
               <a:lnSpc>
                 <a:spcPct val="100000"/>
               </a:lnSpc>
             </a:pPr>
             <a:r>
-              <a:rPr sz="6300" i="0">
+              <a:rPr sz="5400" i="0">
                 <a:solidFill>
                   <a:srgbClr val="22232B"/>
                 </a:solidFill>
                 <a:latin typeface="Bodoni Moda"/>
               </a:rPr>
-              <a:t>x</a:t>
-            </a:r>
-          </a:p>
-        </p:txBody>
-      </p:sp>
-      <p:sp>
-        <p:nvSpPr>
-          <p:cNvPr id="3" name="Rectangle 2"/>
-          <p:cNvSpPr/>
-          <p:nvPr/>
-        </p:nvSpPr>
-        <p:spPr>
-          <a:xfrm>
-            <a:off x="914400" y="7067550"/>
-            <a:ext cx="1143000" cy="28575"/>
-          </a:xfrm>
-          <a:prstGeom prst="rect">
-            <a:avLst/>
-          </a:prstGeom>
-          <a:solidFill>
-            <a:srgbClr val="8E5A5E"/>
-          </a:solidFill>
-          <a:ln>
-            <a:noFill/>
-          </a:ln>
-        </p:spPr>
-        <p:style>
-          <a:lnRef idx="1">
-            <a:schemeClr val="accent1"/>
-          </a:lnRef>
-          <a:fillRef idx="3">
-            <a:schemeClr val="accent1"/>
-          </a:fillRef>
-          <a:effectRef idx="2">
-            <a:schemeClr val="accent1"/>
-          </a:effectRef>
-          <a:fontRef idx="minor">
-            <a:schemeClr val="lt1"/>
-          </a:fontRef>
-        </p:style>
-        <p:txBody>
-          <a:bodyPr rtlCol="0" anchor="ctr"/>
-          <a:lstStyle/>
-          <a:p>
-            <a:pPr algn="ctr"/>
-          </a:p>
-        </p:txBody>
-      </p:sp>
-      <p:sp>
-        <p:nvSpPr>
-          <p:cNvPr id="4" name="TextBox 3"/>
+              <a:t>The Wedding Creators, </a:t>
+            </a:r>
+            <a:r>
+              <a:rPr sz="5400" i="1">
+                <a:solidFill>
+                  <a:srgbClr val="8E5A5E"/>
+                </a:solidFill>
+                <a:latin typeface="Bodoni Moda"/>
+              </a:rPr>
+              <a:t>en cuatro etapas</a:t>
+            </a:r>
+          </a:p>
+        </p:txBody>
+      </p:sp>
+      <p:sp>
+        <p:nvSpPr>
+          <p:cNvPr id="5" name="TextBox 4"/>
           <p:cNvSpPr txBox="1"/>
           <p:nvPr/>
         </p:nvSpPr>
         <p:spPr>
           <a:xfrm>
-            <a:off x="914400" y="666750"/>
-            <a:ext cx="6667500" cy="476250"/>
+            <a:off x="857250" y="3699510"/>
+            <a:ext cx="8572500" cy="596265"/>
           </a:xfrm>
           <a:prstGeom prst="rect">
             <a:avLst/>
@@ -4317,6 +4470,45 @@
           </a:bodyPr>
           <a:lstStyle/>
           <a:p>
+            <a:pPr algn="ctr">
+              <a:lnSpc>
+                <a:spcPct val="120000"/>
+              </a:lnSpc>
+            </a:pPr>
+            <a:r>
+              <a:rPr sz="2550" i="0">
+                <a:solidFill>
+                  <a:srgbClr val="22232B"/>
+                </a:solidFill>
+                <a:latin typeface="Jost"/>
+              </a:rPr>
+              <a:t>El oficio · Tu negocio · Visibilidad · Clientas y experiencia</a:t>
+            </a:r>
+          </a:p>
+        </p:txBody>
+      </p:sp>
+      <p:sp>
+        <p:nvSpPr>
+          <p:cNvPr id="6" name="TextBox 5"/>
+          <p:cNvSpPr txBox="1"/>
+          <p:nvPr/>
+        </p:nvSpPr>
+        <p:spPr>
+          <a:xfrm>
+            <a:off x="914400" y="666750"/>
+            <a:ext cx="6667500" cy="476250"/>
+          </a:xfrm>
+          <a:prstGeom prst="rect">
+            <a:avLst/>
+          </a:prstGeom>
+          <a:noFill/>
+        </p:spPr>
+        <p:txBody>
+          <a:bodyPr wrap="square" anchor="t" lIns="0" rIns="0" tIns="0" bIns="0">
+            <a:spAutoFit/>
+          </a:bodyPr>
+          <a:lstStyle/>
+          <a:p>
             <a:pPr algn="l"/>
             <a:r>
               <a:rPr sz="2550" i="0">
@@ -4341,7 +4533,7 @@
       </p:sp>
       <p:sp>
         <p:nvSpPr>
-          <p:cNvPr id="5" name="TextBox 4"/>
+          <p:cNvPr id="7" name="TextBox 6"/>
           <p:cNvSpPr txBox="1"/>
           <p:nvPr/>
         </p:nvSpPr>

</xml_diff>